<commit_message>
Updated dates and QR codes
</commit_message>
<xml_diff>
--- a/Slides/QLS-MiCM_DataProcessingInPython.pptx
+++ b/Slides/QLS-MiCM_DataProcessingInPython.pptx
@@ -238,7 +238,7 @@
           <a:p>
             <a:fld id="{9FF74AA5-8A3E-4FDB-94BB-BF4B31CB4E38}" type="datetimeFigureOut">
               <a:rPr lang="en-CA" smtClean="0"/>
-              <a:t>2026-03-06</a:t>
+              <a:t>2026-06-16</a:t>
             </a:fld>
             <a:endParaRPr lang="en-CA"/>
           </a:p>
@@ -415,7 +415,7 @@
           <a:p>
             <a:fld id="{217E5156-1B5D-054E-B5B2-E1B1BA160252}" type="datetimeFigureOut">
               <a:rPr lang="fr-FR" smtClean="0"/>
-              <a:t>06/03/2026</a:t>
+              <a:t>16/06/2026</a:t>
             </a:fld>
             <a:endParaRPr lang="fr-FR"/>
           </a:p>
@@ -2980,7 +2980,7 @@
               <a:rPr lang="en-CA" sz="1800" dirty="0">
                 <a:latin typeface="Helvetica Light"/>
               </a:rPr>
-              <a:t>Lead: Benjamin Z. Rudski</a:t>
+              <a:t>Lead: Sameena Karsan</a:t>
             </a:r>
           </a:p>
           <a:p>
@@ -2988,15 +2988,15 @@
               <a:rPr lang="en-CA" sz="1800" dirty="0">
                 <a:latin typeface="Helvetica Light"/>
               </a:rPr>
-              <a:t>Facilitator: James Randolph</a:t>
+              <a:t>Facilitator: Anna Zaidi</a:t>
             </a:r>
           </a:p>
           <a:p>
             <a:r>
-              <a:rPr lang="en-CA" sz="1800" dirty="0">
+              <a:rPr lang="en-CA" sz="1800">
                 <a:latin typeface="Helvetica Light"/>
               </a:rPr>
-              <a:t>March 11, 2026</a:t>
+              <a:t>June 16, 2026</a:t>
             </a:r>
             <a:endParaRPr lang="en-CA" dirty="0">
               <a:latin typeface="Helvetica Light"/>
@@ -14120,10 +14120,10 @@
       </p:sp>
       <p:pic>
         <p:nvPicPr>
-          <p:cNvPr id="2" name="Picture 1">
+          <p:cNvPr id="5" name="Picture 4">
             <a:extLst>
               <a:ext uri="{FF2B5EF4-FFF2-40B4-BE49-F238E27FC236}">
-                <a16:creationId xmlns:a16="http://schemas.microsoft.com/office/drawing/2014/main" id="{6C69662F-A1C2-FE8A-835A-B5EA24525124}"/>
+                <a16:creationId xmlns:a16="http://schemas.microsoft.com/office/drawing/2014/main" id="{89C30577-92C0-D4A6-33C8-B5AB0C9DEF38}"/>
               </a:ext>
             </a:extLst>
           </p:cNvPr>
@@ -14134,13 +14134,14 @@
         </p:nvPicPr>
         <p:blipFill>
           <a:blip r:embed="rId4"/>
-          <a:srcRect/>
-          <a:stretch/>
+          <a:stretch>
+            <a:fillRect/>
+          </a:stretch>
         </p:blipFill>
         <p:spPr>
           <a:xfrm>
-            <a:off x="932417" y="1941932"/>
-            <a:ext cx="7279166" cy="3572184"/>
+            <a:off x="2857499" y="1941932"/>
+            <a:ext cx="3429001" cy="3429001"/>
           </a:xfrm>
           <a:prstGeom prst="rect">
             <a:avLst/>
@@ -14281,7 +14282,7 @@
                 <a:latin typeface="Arial" panose="020B0604020202020204" pitchFamily="34" charset="0"/>
                 <a:ea typeface="Calibri" panose="020F0502020204030204" pitchFamily="34" charset="0"/>
               </a:rPr>
-              <a:t>In this 4-hour workshop, students will learn basic data processing skills using Python. Attendees will learn how to import code from other modules and packages to take advantage of the existing Python ecosystem. After seeing how to access packages, we will explore popular data analysis packages. We will see how to use NumPy to perform operations on large data arrays and how to use Matplotlib to generate clear data visualisations. We will also scratch the surface on using pandas to store data in tables. Along the way, we will discuss how to approach a new, unfamiliar package and learn how to use it.</a:t>
+              <a:t>In this 2-hour workshop, students will learn basic data processing skills using Python. Attendees will learn how to import code from other modules and packages to take advantage of the existing Python ecosystem. After seeing how to access packages, we will explore popular data analysis packages. We will see how to use NumPy to perform operations on large data arrays and how to use Matplotlib to generate clear data visualisations. We will also scratch the surface on using pandas to store data in tables. Along the way, we will discuss how to approach a new, unfamiliar package and learn how to use it.</a:t>
             </a:r>
             <a:endParaRPr lang="en-CA" sz="1800" b="1" dirty="0">
               <a:effectLst/>
@@ -15083,7 +15084,7 @@
                 <a:latin typeface="Arial" panose="020B0604020202020204" pitchFamily="34" charset="0"/>
                 <a:cs typeface="Arial" panose="020B0604020202020204" pitchFamily="34" charset="0"/>
               </a:rPr>
-              <a:t>Module 1 – Modules and Packages (40 minutes)</a:t>
+              <a:t>Module 1 – Modules and Packages (20 minutes)</a:t>
             </a:r>
             <a:endParaRPr lang="en-CA" sz="2000" dirty="0">
               <a:latin typeface="Arial" panose="020B0604020202020204" pitchFamily="34" charset="0"/>
@@ -15163,7 +15164,7 @@
                 <a:latin typeface="Arial" panose="020B0604020202020204" pitchFamily="34" charset="0"/>
                 <a:cs typeface="Arial" panose="020B0604020202020204" pitchFamily="34" charset="0"/>
               </a:rPr>
-              <a:t>Module 2 – Introduction to NumPy Arrays (50 minutes)</a:t>
+              <a:t>Module 2 – Introduction to NumPy Arrays (30 minutes)</a:t>
             </a:r>
             <a:endParaRPr lang="en-CA" sz="2000" dirty="0">
               <a:latin typeface="Arial" panose="020B0604020202020204" pitchFamily="34" charset="0"/>
@@ -15761,7 +15762,7 @@
                 <a:latin typeface="Arial" panose="020B0604020202020204" pitchFamily="34" charset="0"/>
                 <a:cs typeface="Arial" panose="020B0604020202020204" pitchFamily="34" charset="0"/>
               </a:rPr>
-              <a:t>Module 3 – Visualising Data with Matplotlib (50 minutes)</a:t>
+              <a:t>Module 3 – Visualising Data with Matplotlib (30 minutes)</a:t>
             </a:r>
             <a:endParaRPr lang="en-CA" sz="2000" dirty="0">
               <a:latin typeface="Arial" panose="020B0604020202020204" pitchFamily="34" charset="0"/>

</xml_diff>